<commit_message>
IG School 31/10: piezas con fotos y capturas (editables en Canva)
Co-Authored-By: Claude Opus 5.5 <noreply@anthropic.com>
Claude-Session: https://claude.ai/code/session_01QDay3FvCRbiXcjNyUHfpJ1
</commit_message>
<xml_diff>
--- a/public/ig/2026-10-31-listas/carrusel-canva.pptx
+++ b/public/ig/2026-10-31-listas/carrusel-canva.pptx
@@ -3108,7 +3108,7 @@
         <p:spPr>
           <a:xfrm>
             <a:off x="0" y="0"/>
-            <a:ext cx="10287000" cy="9258300"/>
+            <a:ext cx="10287000" cy="7972425"/>
           </a:xfrm>
           <a:prstGeom prst="rect">
             <a:avLst/>
@@ -3142,41 +3142,30 @@
           </a:p>
         </p:txBody>
       </p:sp>
-      <p:sp>
-        <p:nvSpPr>
-          <p:cNvPr id="3" name="TextBox 2"/>
-          <p:cNvSpPr txBox="1"/>
+      <p:pic>
+        <p:nvPicPr>
+          <p:cNvPr id="3" name="Picture 2" descr="image.jpg"/>
+          <p:cNvPicPr>
+            <a:picLocks noChangeAspect="1"/>
+          </p:cNvPicPr>
           <p:nvPr/>
-        </p:nvSpPr>
+        </p:nvPicPr>
+        <p:blipFill>
+          <a:blip r:embed="rId2"/>
+          <a:stretch>
+            <a:fillRect/>
+          </a:stretch>
+        </p:blipFill>
         <p:spPr>
           <a:xfrm>
-            <a:off x="1524000" y="3200400"/>
-            <a:ext cx="7239000" cy="2857500"/>
+            <a:off x="0" y="0"/>
+            <a:ext cx="10287000" cy="7972425"/>
           </a:xfrm>
           <a:prstGeom prst="rect">
             <a:avLst/>
           </a:prstGeom>
-          <a:noFill/>
         </p:spPr>
-        <p:txBody>
-          <a:bodyPr wrap="square" anchor="ctr" lIns="0" rIns="0" tIns="0" bIns="0">
-            <a:spAutoFit/>
-          </a:bodyPr>
-          <a:lstStyle/>
-          <a:p>
-            <a:pPr algn="ctr"/>
-            <a:r>
-              <a:rPr sz="2200" i="0">
-                <a:solidFill>
-                  <a:srgbClr val="22232B"/>
-                </a:solidFill>
-                <a:latin typeface="Jost"/>
-              </a:rPr>
-              <a:t>Aquí va una foto: vuestra mesa de trabajo un sábado por la mañana: portátil, libreta, café y unas flores (manos de Pilar o Ainoa, sin caras de parejas ni alumnas)</a:t>
-            </a:r>
-          </a:p>
-        </p:txBody>
-      </p:sp>
+      </p:pic>
       <p:sp>
         <p:nvSpPr>
           <p:cNvPr id="4" name="TextBox 3"/>
@@ -3185,8 +3174,8 @@
         </p:nvSpPr>
         <p:spPr>
           <a:xfrm>
-            <a:off x="914400" y="9544050"/>
-            <a:ext cx="8458200" cy="3028950"/>
+            <a:off x="914400" y="8258175"/>
+            <a:ext cx="8458200" cy="4314825"/>
           </a:xfrm>
           <a:prstGeom prst="rect">
             <a:avLst/>
@@ -3278,14 +3267,81 @@
       <p:grpSpPr/>
       <p:sp>
         <p:nvSpPr>
-          <p:cNvPr id="2" name="TextBox 1"/>
+          <p:cNvPr id="2" name="Rectangle 1"/>
+          <p:cNvSpPr/>
+          <p:nvPr/>
+        </p:nvSpPr>
+        <p:spPr>
+          <a:xfrm>
+            <a:off x="0" y="0"/>
+            <a:ext cx="10287000" cy="5915025"/>
+          </a:xfrm>
+          <a:prstGeom prst="rect">
+            <a:avLst/>
+          </a:prstGeom>
+          <a:solidFill>
+            <a:srgbClr val="F2E8E8"/>
+          </a:solidFill>
+          <a:ln>
+            <a:noFill/>
+          </a:ln>
+        </p:spPr>
+        <p:style>
+          <a:lnRef idx="1">
+            <a:schemeClr val="accent1"/>
+          </a:lnRef>
+          <a:fillRef idx="3">
+            <a:schemeClr val="accent1"/>
+          </a:fillRef>
+          <a:effectRef idx="2">
+            <a:schemeClr val="accent1"/>
+          </a:effectRef>
+          <a:fontRef idx="minor">
+            <a:schemeClr val="lt1"/>
+          </a:fontRef>
+        </p:style>
+        <p:txBody>
+          <a:bodyPr rtlCol="0" anchor="ctr"/>
+          <a:lstStyle/>
+          <a:p>
+            <a:pPr algn="ctr"/>
+          </a:p>
+        </p:txBody>
+      </p:sp>
+      <p:pic>
+        <p:nvPicPr>
+          <p:cNvPr id="3" name="Picture 2" descr="image.jpg"/>
+          <p:cNvPicPr>
+            <a:picLocks noChangeAspect="1"/>
+          </p:cNvPicPr>
+          <p:nvPr/>
+        </p:nvPicPr>
+        <p:blipFill>
+          <a:blip r:embed="rId2"/>
+          <a:stretch>
+            <a:fillRect/>
+          </a:stretch>
+        </p:blipFill>
+        <p:spPr>
+          <a:xfrm>
+            <a:off x="2777490" y="0"/>
+            <a:ext cx="4732020" cy="5915025"/>
+          </a:xfrm>
+          <a:prstGeom prst="rect">
+            <a:avLst/>
+          </a:prstGeom>
+        </p:spPr>
+      </p:pic>
+      <p:sp>
+        <p:nvSpPr>
+          <p:cNvPr id="4" name="TextBox 3"/>
           <p:cNvSpPr txBox="1"/>
           <p:nvPr/>
         </p:nvSpPr>
         <p:spPr>
           <a:xfrm>
-            <a:off x="914400" y="1047750"/>
-            <a:ext cx="8458200" cy="9715500"/>
+            <a:off x="914400" y="6200775"/>
+            <a:ext cx="8458200" cy="6372225"/>
           </a:xfrm>
           <a:prstGeom prst="rect">
             <a:avLst/>
@@ -3298,7 +3354,7 @@
           </a:bodyPr>
           <a:lstStyle/>
           <a:p>
-            <a:pPr>
+            <a:pPr algn="ctr">
               <a:spcAft>
                 <a:spcPts val="3000"/>
               </a:spcAft>
@@ -3314,13 +3370,13 @@
             </a:r>
           </a:p>
           <a:p>
-            <a:pPr>
+            <a:pPr algn="ctr">
               <a:lnSpc>
                 <a:spcPct val="100000"/>
               </a:lnSpc>
             </a:pPr>
             <a:r>
-              <a:rPr sz="7200" i="0">
+              <a:rPr sz="5700" i="0">
                 <a:solidFill>
                   <a:srgbClr val="22232B"/>
                 </a:solidFill>
@@ -3329,7 +3385,7 @@
               <a:t>Empiezas el </a:t>
             </a:r>
             <a:r>
-              <a:rPr sz="7200" i="1">
+              <a:rPr sz="5700" i="1">
                 <a:solidFill>
                   <a:srgbClr val="22232B"/>
                 </a:solidFill>
@@ -3339,22 +3395,57 @@
             </a:r>
           </a:p>
           <a:p>
-            <a:pPr>
+            <a:pPr algn="ctr">
               <a:lnSpc>
                 <a:spcPct val="140000"/>
               </a:lnSpc>
               <a:spcBef>
-                <a:spcPts val="3600"/>
+                <a:spcPts val="2000"/>
               </a:spcBef>
             </a:pPr>
             <a:r>
-              <a:rPr sz="2800" i="0">
+              <a:rPr sz="2500" i="0">
                 <a:solidFill>
                   <a:srgbClr val="6B6D78"/>
                 </a:solidFill>
                 <a:latin typeface="Jost"/>
               </a:rPr>
               <a:t>Una lección al día, a tu ritmo, desde el sofá o la mesa de la cocina. Sin dejar tu trabajo y sin experiencia previa.</a:t>
+            </a:r>
+          </a:p>
+        </p:txBody>
+      </p:sp>
+      <p:sp>
+        <p:nvSpPr>
+          <p:cNvPr id="5" name="TextBox 4"/>
+          <p:cNvSpPr txBox="1"/>
+          <p:nvPr/>
+        </p:nvSpPr>
+        <p:spPr>
+          <a:xfrm>
+            <a:off x="7429500" y="571500"/>
+            <a:ext cx="1943100" cy="476250"/>
+          </a:xfrm>
+          <a:prstGeom prst="rect">
+            <a:avLst/>
+          </a:prstGeom>
+          <a:noFill/>
+        </p:spPr>
+        <p:txBody>
+          <a:bodyPr wrap="square" anchor="ctr" lIns="0" rIns="0" tIns="0" bIns="0">
+            <a:spAutoFit/>
+          </a:bodyPr>
+          <a:lstStyle/>
+          <a:p>
+            <a:pPr algn="r"/>
+            <a:r>
+              <a:rPr sz="2100" i="0" spc="400">
+                <a:solidFill>
+                  <a:srgbClr val="8E5A5E"/>
+                </a:solidFill>
+                <a:latin typeface="Jost"/>
+              </a:rPr>
+              <a:t>2 / 4</a:t>
             </a:r>
           </a:p>
         </p:txBody>
@@ -3387,14 +3478,81 @@
       <p:grpSpPr/>
       <p:sp>
         <p:nvSpPr>
-          <p:cNvPr id="2" name="TextBox 1"/>
+          <p:cNvPr id="2" name="Rectangle 1"/>
+          <p:cNvSpPr/>
+          <p:nvPr/>
+        </p:nvSpPr>
+        <p:spPr>
+          <a:xfrm>
+            <a:off x="0" y="0"/>
+            <a:ext cx="10287000" cy="5915025"/>
+          </a:xfrm>
+          <a:prstGeom prst="rect">
+            <a:avLst/>
+          </a:prstGeom>
+          <a:solidFill>
+            <a:srgbClr val="F3F3F5"/>
+          </a:solidFill>
+          <a:ln>
+            <a:noFill/>
+          </a:ln>
+        </p:spPr>
+        <p:style>
+          <a:lnRef idx="1">
+            <a:schemeClr val="accent1"/>
+          </a:lnRef>
+          <a:fillRef idx="3">
+            <a:schemeClr val="accent1"/>
+          </a:fillRef>
+          <a:effectRef idx="2">
+            <a:schemeClr val="accent1"/>
+          </a:effectRef>
+          <a:fontRef idx="minor">
+            <a:schemeClr val="lt1"/>
+          </a:fontRef>
+        </p:style>
+        <p:txBody>
+          <a:bodyPr rtlCol="0" anchor="ctr"/>
+          <a:lstStyle/>
+          <a:p>
+            <a:pPr algn="ctr"/>
+          </a:p>
+        </p:txBody>
+      </p:sp>
+      <p:pic>
+        <p:nvPicPr>
+          <p:cNvPr id="3" name="Picture 2" descr="image.jpg"/>
+          <p:cNvPicPr>
+            <a:picLocks noChangeAspect="1"/>
+          </p:cNvPicPr>
+          <p:nvPr/>
+        </p:nvPicPr>
+        <p:blipFill>
+          <a:blip r:embed="rId2"/>
+          <a:stretch>
+            <a:fillRect/>
+          </a:stretch>
+        </p:blipFill>
+        <p:spPr>
+          <a:xfrm>
+            <a:off x="0" y="0"/>
+            <a:ext cx="10287000" cy="5915025"/>
+          </a:xfrm>
+          <a:prstGeom prst="rect">
+            <a:avLst/>
+          </a:prstGeom>
+        </p:spPr>
+      </p:pic>
+      <p:sp>
+        <p:nvSpPr>
+          <p:cNvPr id="4" name="TextBox 3"/>
           <p:cNvSpPr txBox="1"/>
           <p:nvPr/>
         </p:nvSpPr>
         <p:spPr>
           <a:xfrm>
-            <a:off x="914400" y="1047750"/>
-            <a:ext cx="8458200" cy="9715500"/>
+            <a:off x="914400" y="6200775"/>
+            <a:ext cx="8458200" cy="6372225"/>
           </a:xfrm>
           <a:prstGeom prst="rect">
             <a:avLst/>
@@ -3407,7 +3565,7 @@
           </a:bodyPr>
           <a:lstStyle/>
           <a:p>
-            <a:pPr>
+            <a:pPr algn="ctr">
               <a:spcAft>
                 <a:spcPts val="3000"/>
               </a:spcAft>
@@ -3423,13 +3581,13 @@
             </a:r>
           </a:p>
           <a:p>
-            <a:pPr>
+            <a:pPr algn="ctr">
               <a:lnSpc>
                 <a:spcPct val="100000"/>
               </a:lnSpc>
             </a:pPr>
             <a:r>
-              <a:rPr sz="7200" i="0">
+              <a:rPr sz="5700" i="0">
                 <a:solidFill>
                   <a:srgbClr val="22232B"/>
                 </a:solidFill>
@@ -3438,7 +3596,7 @@
               <a:t>Planificas tu boda </a:t>
             </a:r>
             <a:r>
-              <a:rPr sz="7200" i="1">
+              <a:rPr sz="5700" i="1">
                 <a:solidFill>
                   <a:srgbClr val="22232B"/>
                 </a:solidFill>
@@ -3448,22 +3606,57 @@
             </a:r>
           </a:p>
           <a:p>
-            <a:pPr>
+            <a:pPr algn="ctr">
               <a:lnSpc>
                 <a:spcPct val="140000"/>
               </a:lnSpc>
               <a:spcBef>
-                <a:spcPts val="3600"/>
+                <a:spcPts val="2000"/>
               </a:spcBef>
             </a:pPr>
             <a:r>
-              <a:rPr sz="2800" i="0">
+              <a:rPr sz="2500" i="0">
                 <a:solidFill>
                   <a:srgbClr val="6B6D78"/>
                 </a:solidFill>
                 <a:latin typeface="Jost"/>
               </a:rPr>
               <a:t>Clara y Marc: 110 invitados, Costa Brava, 38.000 € de presupuesto. Con nuestras 4 herramientas y con nosotras en el grupo de WhatsApp.</a:t>
+            </a:r>
+          </a:p>
+        </p:txBody>
+      </p:sp>
+      <p:sp>
+        <p:nvSpPr>
+          <p:cNvPr id="5" name="TextBox 4"/>
+          <p:cNvSpPr txBox="1"/>
+          <p:nvPr/>
+        </p:nvSpPr>
+        <p:spPr>
+          <a:xfrm>
+            <a:off x="7429500" y="571500"/>
+            <a:ext cx="1943100" cy="476250"/>
+          </a:xfrm>
+          <a:prstGeom prst="rect">
+            <a:avLst/>
+          </a:prstGeom>
+          <a:noFill/>
+        </p:spPr>
+        <p:txBody>
+          <a:bodyPr wrap="square" anchor="ctr" lIns="0" rIns="0" tIns="0" bIns="0">
+            <a:spAutoFit/>
+          </a:bodyPr>
+          <a:lstStyle/>
+          <a:p>
+            <a:pPr algn="r"/>
+            <a:r>
+              <a:rPr sz="2100" i="0" spc="400">
+                <a:solidFill>
+                  <a:srgbClr val="8E5A5E"/>
+                </a:solidFill>
+                <a:latin typeface="Jost"/>
+              </a:rPr>
+              <a:t>3 / 4</a:t>
             </a:r>
           </a:p>
         </p:txBody>
@@ -3496,14 +3689,81 @@
       <p:grpSpPr/>
       <p:sp>
         <p:nvSpPr>
-          <p:cNvPr id="2" name="TextBox 1"/>
+          <p:cNvPr id="2" name="Rectangle 1"/>
+          <p:cNvSpPr/>
+          <p:nvPr/>
+        </p:nvSpPr>
+        <p:spPr>
+          <a:xfrm>
+            <a:off x="0" y="0"/>
+            <a:ext cx="10287000" cy="4629150"/>
+          </a:xfrm>
+          <a:prstGeom prst="rect">
+            <a:avLst/>
+          </a:prstGeom>
+          <a:solidFill>
+            <a:srgbClr val="F2E8E8"/>
+          </a:solidFill>
+          <a:ln>
+            <a:noFill/>
+          </a:ln>
+        </p:spPr>
+        <p:style>
+          <a:lnRef idx="1">
+            <a:schemeClr val="accent1"/>
+          </a:lnRef>
+          <a:fillRef idx="3">
+            <a:schemeClr val="accent1"/>
+          </a:fillRef>
+          <a:effectRef idx="2">
+            <a:schemeClr val="accent1"/>
+          </a:effectRef>
+          <a:fontRef idx="minor">
+            <a:schemeClr val="lt1"/>
+          </a:fontRef>
+        </p:style>
+        <p:txBody>
+          <a:bodyPr rtlCol="0" anchor="ctr"/>
+          <a:lstStyle/>
+          <a:p>
+            <a:pPr algn="ctr"/>
+          </a:p>
+        </p:txBody>
+      </p:sp>
+      <p:pic>
+        <p:nvPicPr>
+          <p:cNvPr id="3" name="Picture 2" descr="image.jpg"/>
+          <p:cNvPicPr>
+            <a:picLocks noChangeAspect="1"/>
+          </p:cNvPicPr>
+          <p:nvPr/>
+        </p:nvPicPr>
+        <p:blipFill>
+          <a:blip r:embed="rId2"/>
+          <a:stretch>
+            <a:fillRect/>
+          </a:stretch>
+        </p:blipFill>
+        <p:spPr>
+          <a:xfrm>
+            <a:off x="0" y="0"/>
+            <a:ext cx="10287000" cy="4629150"/>
+          </a:xfrm>
+          <a:prstGeom prst="rect">
+            <a:avLst/>
+          </a:prstGeom>
+        </p:spPr>
+      </p:pic>
+      <p:sp>
+        <p:nvSpPr>
+          <p:cNvPr id="4" name="TextBox 3"/>
           <p:cNvSpPr txBox="1"/>
           <p:nvPr/>
         </p:nvSpPr>
         <p:spPr>
           <a:xfrm>
-            <a:off x="914400" y="1047750"/>
-            <a:ext cx="8458200" cy="9715500"/>
+            <a:off x="914400" y="4914900"/>
+            <a:ext cx="8458200" cy="7658100"/>
           </a:xfrm>
           <a:prstGeom prst="rect">
             <a:avLst/>
@@ -3516,7 +3776,7 @@
           </a:bodyPr>
           <a:lstStyle/>
           <a:p>
-            <a:pPr>
+            <a:pPr algn="ctr">
               <a:spcAft>
                 <a:spcPts val="3000"/>
               </a:spcAft>
@@ -3532,13 +3792,13 @@
             </a:r>
           </a:p>
           <a:p>
-            <a:pPr>
+            <a:pPr algn="ctr">
               <a:lnSpc>
                 <a:spcPct val="100000"/>
               </a:lnSpc>
             </a:pPr>
             <a:r>
-              <a:rPr sz="7200" i="0">
+              <a:rPr sz="5700" i="0">
                 <a:solidFill>
                   <a:srgbClr val="F3F3F5"/>
                 </a:solidFill>
@@ -3547,7 +3807,7 @@
               <a:t>Tu primera boda, </a:t>
             </a:r>
             <a:r>
-              <a:rPr sz="7200" i="1">
+              <a:rPr sz="5700" i="1">
                 <a:solidFill>
                   <a:srgbClr val="F3F3F5"/>
                 </a:solidFill>
@@ -3557,16 +3817,16 @@
             </a:r>
           </a:p>
           <a:p>
-            <a:pPr>
+            <a:pPr algn="ctr">
               <a:lnSpc>
                 <a:spcPct val="140000"/>
               </a:lnSpc>
               <a:spcBef>
-                <a:spcPts val="3600"/>
+                <a:spcPts val="2000"/>
               </a:spcBef>
             </a:pPr>
             <a:r>
-              <a:rPr sz="2800" i="0">
+              <a:rPr sz="2500" i="0">
                 <a:solidFill>
                   <a:srgbClr val="F3F3F5"/>
                 </a:solidFill>
@@ -3576,7 +3836,7 @@
             </a:r>
             <a:br/>
             <a:r>
-              <a:rPr sz="2800" i="0">
+              <a:rPr sz="2500" i="0">
                 <a:solidFill>
                   <a:srgbClr val="F3F3F5"/>
                 </a:solidFill>
@@ -3586,9 +3846,9 @@
             </a:r>
           </a:p>
           <a:p>
-            <a:pPr>
+            <a:pPr algn="ctr">
               <a:spcBef>
-                <a:spcPts val="4800"/>
+                <a:spcPts val="2800"/>
               </a:spcBef>
             </a:pPr>
             <a:r>
@@ -3599,6 +3859,41 @@
                 <a:latin typeface="Jost"/>
               </a:rPr>
               <a:t>ESCRÍBENOS CURSO</a:t>
+            </a:r>
+          </a:p>
+        </p:txBody>
+      </p:sp>
+      <p:sp>
+        <p:nvSpPr>
+          <p:cNvPr id="5" name="TextBox 4"/>
+          <p:cNvSpPr txBox="1"/>
+          <p:nvPr/>
+        </p:nvSpPr>
+        <p:spPr>
+          <a:xfrm>
+            <a:off x="7429500" y="571500"/>
+            <a:ext cx="1943100" cy="476250"/>
+          </a:xfrm>
+          <a:prstGeom prst="rect">
+            <a:avLst/>
+          </a:prstGeom>
+          <a:noFill/>
+        </p:spPr>
+        <p:txBody>
+          <a:bodyPr wrap="square" anchor="ctr" lIns="0" rIns="0" tIns="0" bIns="0">
+            <a:spAutoFit/>
+          </a:bodyPr>
+          <a:lstStyle/>
+          <a:p>
+            <a:pPr algn="r"/>
+            <a:r>
+              <a:rPr sz="2100" i="0" spc="400">
+                <a:solidFill>
+                  <a:srgbClr val="8E5A5E"/>
+                </a:solidFill>
+                <a:latin typeface="Jost"/>
+              </a:rPr>
+              <a:t>4 / 4</a:t>
             </a:r>
           </a:p>
         </p:txBody>

</xml_diff>